<commit_message>
Update README and exercise files: add images, refine content, and reorganize structure for clarity
</commit_message>
<xml_diff>
--- a/templates/AI Agent Canvas Template.pptx
+++ b/templates/AI Agent Canvas Template.pptx
@@ -13645,7 +13645,7 @@
         </p:nvSpPr>
         <p:spPr>
           <a:xfrm>
-            <a:off x="471727" y="1281379"/>
+            <a:off x="460415" y="1175123"/>
             <a:ext cx="1465800" cy="2248500"/>
           </a:xfrm>
           <a:prstGeom prst="rect">
@@ -13765,7 +13765,7 @@
         </p:nvSpPr>
         <p:spPr>
           <a:xfrm>
-            <a:off x="2169881" y="1242779"/>
+            <a:off x="2158569" y="1143441"/>
             <a:ext cx="1518600" cy="936000"/>
           </a:xfrm>
           <a:prstGeom prst="rect">
@@ -13792,7 +13792,7 @@
               <a:buNone/>
             </a:pPr>
             <a:r>
-              <a:rPr lang="en" sz="900">
+              <a:rPr lang="en" sz="900" dirty="0">
                 <a:solidFill>
                   <a:srgbClr val="333333"/>
                 </a:solidFill>
@@ -13814,7 +13814,7 @@
               <a:buNone/>
             </a:pPr>
             <a:r>
-              <a:rPr lang="en" sz="900">
+              <a:rPr lang="en" sz="900" dirty="0">
                 <a:solidFill>
                   <a:srgbClr val="333333"/>
                 </a:solidFill>

</xml_diff>